<commit_message>
S6 deck fixes from John's slide review: road slide shrink-to-fit (83), sample restoration blessing on the demo slide (87), pairs order made pair-true across 88-89 + notes (parents first, Companion residue removed), 'walk my brothers and sisters home' (90); changelog v2.11; S3 storytelling sibling flagged
Co-Authored-By: Claude Fable 5 <noreply@anthropic.com>
</commit_message>
<xml_diff>
--- a/_implementation-notes/evening-series/FotH Evening Session 6 Slides DRAFT v1.pptx
+++ b/_implementation-notes/evening-series/FotH Evening Session 6 Slides DRAFT v1.pptx
@@ -1510,13 +1510,13 @@
           <a:p>
             <a:r>
               <a:rPr lang="en-US" sz="1200"/>
-              <a:t>1. The Companion opens with ninety seconds of silence, then goes first (3 min) and receives the pre-assigned blessing.</a:t>
+              <a:t>1. Ninety seconds of silence to settle — the silence is part of the practice.</a:t>
             </a:r>
           </a:p>
           <a:p>
             <a:r>
               <a:rPr lang="en-US" sz="1200"/>
-              <a:t>2. Parents next, arranged parent opening, within the rails; then the teens at their own depth — pass honored without a flicker. A teen blessing their own parent is one of the best things this night produces.</a:t>
+              <a:t>2. The parent goes first in every pair (3 min), own struggles only, within the rails; then the teens at their own depth — pass honored without a flicker. A teen blessing their own parent is one of the best things this night produces.</a:t>
             </a:r>
           </a:p>
           <a:p>
@@ -5293,7 +5293,7 @@
                 </a:solidFill>
                 <a:latin typeface="Calibri"/>
               </a:rPr>
-              <a:t>The Lead Companion goes first — names one place, receives a blessing</a:t>
+              <a:t>The parents go first in every pair — own struggles only, within the rails</a:t>
             </a:r>
           </a:p>
           <a:p>
@@ -5310,31 +5310,6 @@
                 <a:latin typeface="Calibri"/>
               </a:rPr>
               <a:t>2   </a:t>
-            </a:r>
-            <a:r>
-              <a:rPr sz="2000" b="0" i="0">
-                <a:solidFill>
-                  <a:srgbClr val="222B22"/>
-                </a:solidFill>
-                <a:latin typeface="Calibri"/>
-              </a:rPr>
-              <a:t>The parents next — the arranged parent opens; own struggles only, within the rails</a:t>
-            </a:r>
-          </a:p>
-          <a:p>
-            <a:pPr marL="342900" indent="-342900">
-              <a:spcAft>
-                <a:spcPts val="750"/>
-              </a:spcAft>
-            </a:pPr>
-            <a:r>
-              <a:rPr sz="2000" b="1" i="0">
-                <a:solidFill>
-                  <a:srgbClr val="97BC62"/>
-                </a:solidFill>
-                <a:latin typeface="Calibri"/>
-              </a:rPr>
-              <a:t>3   </a:t>
             </a:r>
             <a:r>
               <a:rPr sz="2000" b="0" i="0">
@@ -5701,7 +5676,7 @@
                 </a:solidFill>
                 <a:latin typeface="Calibri"/>
               </a:rPr>
-              <a:t>“We pray restoration into every place that was named... Holy Spirit, walk these brothers and sisters home.”</a:t>
+              <a:t>“We pray restoration into every place that was named... Holy Spirit, walk my brothers and sisters home.”</a:t>
             </a:r>
           </a:p>
         </p:txBody>
@@ -8160,7 +8135,7 @@
         </p:spPr>
         <p:txBody>
           <a:bodyPr wrap="square">
-            <a:spAutoFit/>
+            <a:normAutofit fontScale="77000" lnSpcReduction="10000"/>
           </a:bodyPr>
           <a:lstStyle/>
           <a:p>
@@ -9348,7 +9323,7 @@
                 </a:solidFill>
                 <a:latin typeface="Calibri"/>
               </a:rPr>
-              <a:t>After each naming, the circle speaks a specific blessing of restoration — about three minutes per person</a:t>
+              <a:t>After each naming, the pair speaks a specific blessing of restoration — about three minutes per person</a:t>
             </a:r>
           </a:p>
         </p:txBody>
@@ -9567,7 +9542,9 @@
           <a:noFill/>
         </p:spPr>
         <p:txBody>
-          <a:bodyPr wrap="square" lIns="91440" tIns="91440" rIns="91440" bIns="91440"/>
+          <a:bodyPr wrap="square" lIns="91440" tIns="91440" rIns="91440" bIns="91440">
+            <a:normAutofit fontScale="80000" lnSpcReduction="10000"/>
+          </a:bodyPr>
           <a:lstStyle/>
           <a:p>
             <a:pPr marL="274320" indent="-274320">
@@ -9667,6 +9644,31 @@
                 <a:latin typeface="Calibri"/>
               </a:rPr>
               <a:t>Pause. A pre-arranged Co-Companion speaks a brief blessing of restoration back</a:t>
+            </a:r>
+          </a:p>
+          <a:p>
+            <a:pPr marL="274320" indent="-274320">
+              <a:spcAft>
+                <a:spcPts val="900"/>
+              </a:spcAft>
+            </a:pPr>
+            <a:r>
+              <a:rPr sz="2400" b="1" i="0">
+                <a:solidFill>
+                  <a:srgbClr val="97BC62"/>
+                </a:solidFill>
+                <a:latin typeface="Calibri"/>
+              </a:rPr>
+              <a:t>•  </a:t>
+            </a:r>
+            <a:r>
+              <a:rPr sz="2400" b="0" i="0">
+                <a:solidFill>
+                  <a:srgbClr val="222B22"/>
+                </a:solidFill>
+                <a:latin typeface="Calibri"/>
+              </a:rPr>
+              <a:t>For example: “In the name of Jesus, we pray restoration over the place you named — may its grip break, and may honesty grow where it held.”</a:t>
             </a:r>
           </a:p>
           <a:p>
@@ -9963,7 +9965,7 @@
                 </a:solidFill>
                 <a:latin typeface="Calibri"/>
               </a:rPr>
-              <a:t>The order holds too: your Companion first, then the parents, then the teens</a:t>
+              <a:t>The order holds in every pair: the parent first, then the teens</a:t>
             </a:r>
           </a:p>
           <a:p>

</xml_diff>

<commit_message>
The homework practice by name + the quarter break leaves the active walk (John's calls on the v2.12 flag): 90 title spots across 45 md records + the template rendition; S6 record/run sheet to 'the two weeks', Pulse removed from S6 deck notes + leader notes commissioning/closing beats, S7 door cue now the 7:25 three-questions block; arc labels kept; S11/S16/S17 quarter-shaped homework held for John's design word; changelog v2.13
Co-Authored-By: Claude Fable 5 <noreply@anthropic.com>
</commit_message>
<xml_diff>
--- a/_implementation-notes/evening-series/FotH Evening Session 6 Slides DRAFT v1.pptx
+++ b/_implementation-notes/evening-series/FotH Evening Session 6 Slides DRAFT v1.pptx
@@ -1068,7 +1068,7 @@
           <a:p>
             <a:r>
               <a:rPr lang="en-US" sz="1200"/>
-              <a:t>2. Shape: open, check-in, 13-minute teaching, YOUR demo, bridge, 33-minute pair practice (Companion, then parents, then teens), merge and shared blessing, Examen plus Quarterly Pulse, feedback, close. Quarter 1 ends today.</a:t>
+              <a:t>2. Shape: open, check-in, 13-minute teaching, YOUR demo, bridge, 33-minute pair practice (Companion, then parents, then teens), merge and shared blessing, Examen plus the three questions carried home, feedback, close. Quarter 1 ends today.</a:t>
             </a:r>
           </a:p>
           <a:p>
@@ -1671,7 +1671,7 @@
           </a:p>
           <a:p>
             <a:r>
-              <a:t>3. (Current-condition walk: no quarter break and no paper Pulse — the three reflection questions ride home as a thinking point, next slide but two.)</a:t>
+              <a:t>3. The three reflection questions ride home as a thinking point — next slide but two.</a:t>
             </a:r>
           </a:p>
         </p:txBody>
@@ -1873,7 +1873,7 @@
           <a:p>
             <a:r>
               <a:rPr lang="en-US" sz="1200"/>
-              <a:t>3. Aaronic blessing. 'Go gently. Today closes the quarter — carry the Examen through the break; bring the Pulse back to the Week 7 door.'</a:t>
+              <a:t>3. Aaronic blessing. 'Go gently. Today closes the quarter — carry the Examen through the two weeks, and bring the three questions with you; next evening, we talk.'</a:t>
             </a:r>
           </a:p>
           <a:p>

</xml_diff>